<commit_message>
docs(pitch): add AI 成本曲线/技术护城河 slide (s4b) + re-screenshot insight-rich 驾驶舱
New slide: 规则优先 × 自蒸馏飞轮 cost-decay curve + three-tier resolver (deck now 8 slides).
Dashboard screenshot updated to show the live 数据驱动 chart-insight bars (销售趋势/产品类别占比/门店排行).

Co-Authored-By: Claude Opus 4.8 (1M context) <noreply@anthropic.com>
</commit_message>
<xml_diff>
--- a/competition/haijuying-cretas-pitch.pptx
+++ b/competition/haijuying-cretas-pitch.pptx
@@ -14,6 +14,7 @@
     <p:sldId id="262" r:id="rId13"/>
     <p:sldId id="263" r:id="rId14"/>
     <p:sldId id="264" r:id="rId15"/>
+    <p:sldId id="265" r:id="rId16"/>
   </p:sldIdLst>
   <p:sldSz cx="12188952" cy="6858000" type="screen4x3"/>
   <p:notesSz cx="6858000" cy="9144000"/>
@@ -3128,6 +3129,48 @@
 </p:sld>
 </file>
 
+<file path=ppt/slides/slide10.xml><?xml version="1.0" encoding="utf-8"?>
+<p:sld xmlns:a="http://schemas.openxmlformats.org/drawingml/2006/main" xmlns:p="http://schemas.openxmlformats.org/presentationml/2006/main" xmlns:r="http://schemas.openxmlformats.org/officeDocument/2006/relationships">
+  <p:cSld>
+    <p:spTree>
+      <p:nvGrpSpPr>
+        <p:cNvPr id="1" name=""/>
+        <p:cNvGrpSpPr/>
+        <p:nvPr/>
+      </p:nvGrpSpPr>
+      <p:grpSpPr/>
+      <p:pic>
+        <p:nvPicPr>
+          <p:cNvPr id="2" name="Picture 1" descr="send.png"/>
+          <p:cNvPicPr>
+            <a:picLocks noChangeAspect="1"/>
+          </p:cNvPicPr>
+          <p:nvPr/>
+        </p:nvPicPr>
+        <p:blipFill>
+          <a:blip r:embed="rId2"/>
+          <a:stretch>
+            <a:fillRect/>
+          </a:stretch>
+        </p:blipFill>
+        <p:spPr>
+          <a:xfrm>
+            <a:off x="0" y="0"/>
+            <a:ext cx="12188952" cy="6858000"/>
+          </a:xfrm>
+          <a:prstGeom prst="rect">
+            <a:avLst/>
+          </a:prstGeom>
+        </p:spPr>
+      </p:pic>
+    </p:spTree>
+  </p:cSld>
+  <p:clrMapOvr>
+    <a:masterClrMapping/>
+  </p:clrMapOvr>
+</p:sld>
+</file>
+
 <file path=ppt/slides/slide2.xml><?xml version="1.0" encoding="utf-8"?>
 <p:sld xmlns:a="http://schemas.openxmlformats.org/drawingml/2006/main" xmlns:p="http://schemas.openxmlformats.org/presentationml/2006/main" xmlns:r="http://schemas.openxmlformats.org/officeDocument/2006/relationships">
   <p:cSld>
@@ -3308,7 +3351,7 @@
       <p:grpSpPr/>
       <p:pic>
         <p:nvPicPr>
-          <p:cNvPr id="2" name="Picture 1" descr="s5.png"/>
+          <p:cNvPr id="2" name="Picture 1" descr="s4b.png"/>
           <p:cNvPicPr>
             <a:picLocks noChangeAspect="1"/>
           </p:cNvPicPr>
@@ -3350,7 +3393,7 @@
       <p:grpSpPr/>
       <p:pic>
         <p:nvPicPr>
-          <p:cNvPr id="2" name="Picture 1" descr="s6.png"/>
+          <p:cNvPr id="2" name="Picture 1" descr="s5.png"/>
           <p:cNvPicPr>
             <a:picLocks noChangeAspect="1"/>
           </p:cNvPicPr>
@@ -3392,7 +3435,7 @@
       <p:grpSpPr/>
       <p:pic>
         <p:nvPicPr>
-          <p:cNvPr id="2" name="Picture 1" descr="s7.png"/>
+          <p:cNvPr id="2" name="Picture 1" descr="s6.png"/>
           <p:cNvPicPr>
             <a:picLocks noChangeAspect="1"/>
           </p:cNvPicPr>
@@ -3434,7 +3477,7 @@
       <p:grpSpPr/>
       <p:pic>
         <p:nvPicPr>
-          <p:cNvPr id="2" name="Picture 1" descr="send.png"/>
+          <p:cNvPr id="2" name="Picture 1" descr="s7.png"/>
           <p:cNvPicPr>
             <a:picLocks noChangeAspect="1"/>
           </p:cNvPicPr>

</xml_diff>